<commit_message>
Fix cropped repository screenshots
Capture complete application views and refresh the presentation assets.

Co-authored-by: Copilot <223556219+Copilot@users.noreply.github.com>
</commit_message>
<xml_diff>
--- a/docs/Fabric-Capacity-Copilot-Overview.pptx
+++ b/docs/Fabric-Capacity-Copilot-Overview.pptx
@@ -132,7 +132,7 @@
           <p:cNvPr id="2" name="Title 1">
             <a:extLst>
               <a:ext uri="{FF2B5EF4-FFF2-40B4-BE49-F238E27FC236}">
-                <a16:creationId xmlns:a16="http://schemas.microsoft.com/office/drawing/2014/main" id="{18F89608-C9BF-7A0E-0D1E-91494C3DDB74}"/>
+                <a16:creationId xmlns:a16="http://schemas.microsoft.com/office/drawing/2014/main" id="{A0582C0B-E16B-6A36-4DE6-348B577ACB34}"/>
               </a:ext>
             </a:extLst>
           </p:cNvPr>
@@ -169,7 +169,7 @@
           <p:cNvPr id="3" name="Subtitle 2">
             <a:extLst>
               <a:ext uri="{FF2B5EF4-FFF2-40B4-BE49-F238E27FC236}">
-                <a16:creationId xmlns:a16="http://schemas.microsoft.com/office/drawing/2014/main" id="{A6FB2B54-08CB-87BE-3464-5C78446D0D1A}"/>
+                <a16:creationId xmlns:a16="http://schemas.microsoft.com/office/drawing/2014/main" id="{B60D6B9F-768F-1A8F-5CB9-4DA1F5343C27}"/>
               </a:ext>
             </a:extLst>
           </p:cNvPr>
@@ -239,7 +239,7 @@
           <p:cNvPr id="4" name="Date Placeholder 3">
             <a:extLst>
               <a:ext uri="{FF2B5EF4-FFF2-40B4-BE49-F238E27FC236}">
-                <a16:creationId xmlns:a16="http://schemas.microsoft.com/office/drawing/2014/main" id="{7AD4834F-A6E9-0A94-2040-7DD158FFFD42}"/>
+                <a16:creationId xmlns:a16="http://schemas.microsoft.com/office/drawing/2014/main" id="{1EB79A9D-0AA0-E347-DA94-2FA5B5EA3730}"/>
               </a:ext>
             </a:extLst>
           </p:cNvPr>
@@ -255,7 +255,7 @@
           <a:bodyPr/>
           <a:lstStyle/>
           <a:p>
-            <a:fld id="{CCA853AE-2B35-4E40-B8A3-67DBCD9E45C2}" type="datetimeFigureOut">
+            <a:fld id="{47A277B0-1BC8-46D0-96E9-4631C913E98E}" type="datetimeFigureOut">
               <a:rPr lang="en-US" smtClean="0"/>
               <a:t>9/20/2026</a:t>
             </a:fld>
@@ -268,7 +268,7 @@
           <p:cNvPr id="5" name="Footer Placeholder 4">
             <a:extLst>
               <a:ext uri="{FF2B5EF4-FFF2-40B4-BE49-F238E27FC236}">
-                <a16:creationId xmlns:a16="http://schemas.microsoft.com/office/drawing/2014/main" id="{205CF3A0-270C-D10C-1620-724BBEF7605D}"/>
+                <a16:creationId xmlns:a16="http://schemas.microsoft.com/office/drawing/2014/main" id="{A2F4DF9E-D49B-8DB2-CCB1-1E70B6985372}"/>
               </a:ext>
             </a:extLst>
           </p:cNvPr>
@@ -293,7 +293,7 @@
           <p:cNvPr id="6" name="Slide Number Placeholder 5">
             <a:extLst>
               <a:ext uri="{FF2B5EF4-FFF2-40B4-BE49-F238E27FC236}">
-                <a16:creationId xmlns:a16="http://schemas.microsoft.com/office/drawing/2014/main" id="{EDE68EB9-3AC6-99E0-A9DB-68EB07559EA1}"/>
+                <a16:creationId xmlns:a16="http://schemas.microsoft.com/office/drawing/2014/main" id="{F3A30A48-A770-0898-4BCE-C285D688A96C}"/>
               </a:ext>
             </a:extLst>
           </p:cNvPr>
@@ -309,7 +309,7 @@
           <a:bodyPr/>
           <a:lstStyle/>
           <a:p>
-            <a:fld id="{B7A613CB-FFFC-4DC9-A6CC-F615930E06AC}" type="slidenum">
+            <a:fld id="{50FEEB4A-BAF6-4C97-B33F-AB910F2FB9EF}" type="slidenum">
               <a:rPr lang="en-US" smtClean="0"/>
               <a:t>‹#›</a:t>
             </a:fld>
@@ -320,7 +320,7 @@
     </p:spTree>
     <p:extLst>
       <p:ext uri="{BB962C8B-B14F-4D97-AF65-F5344CB8AC3E}">
-        <p14:creationId xmlns:p14="http://schemas.microsoft.com/office/powerpoint/2010/main" val="2321572232"/>
+        <p14:creationId xmlns:p14="http://schemas.microsoft.com/office/powerpoint/2010/main" val="514608874"/>
       </p:ext>
     </p:extLst>
   </p:cSld>
@@ -352,7 +352,7 @@
           <p:cNvPr id="2" name="Title 1">
             <a:extLst>
               <a:ext uri="{FF2B5EF4-FFF2-40B4-BE49-F238E27FC236}">
-                <a16:creationId xmlns:a16="http://schemas.microsoft.com/office/drawing/2014/main" id="{80F33A2D-663D-91FB-79D9-68599FA7ED28}"/>
+                <a16:creationId xmlns:a16="http://schemas.microsoft.com/office/drawing/2014/main" id="{1F00101F-FA2F-F926-3425-130582DD1C89}"/>
               </a:ext>
             </a:extLst>
           </p:cNvPr>
@@ -380,7 +380,7 @@
           <p:cNvPr id="3" name="Vertical Text Placeholder 2">
             <a:extLst>
               <a:ext uri="{FF2B5EF4-FFF2-40B4-BE49-F238E27FC236}">
-                <a16:creationId xmlns:a16="http://schemas.microsoft.com/office/drawing/2014/main" id="{65A9454C-365C-617D-07EE-BE14FCBE81B0}"/>
+                <a16:creationId xmlns:a16="http://schemas.microsoft.com/office/drawing/2014/main" id="{DB877A61-4C66-390F-9CFF-DD0E0820F311}"/>
               </a:ext>
             </a:extLst>
           </p:cNvPr>
@@ -437,7 +437,7 @@
           <p:cNvPr id="4" name="Date Placeholder 3">
             <a:extLst>
               <a:ext uri="{FF2B5EF4-FFF2-40B4-BE49-F238E27FC236}">
-                <a16:creationId xmlns:a16="http://schemas.microsoft.com/office/drawing/2014/main" id="{6E9D834D-0AFC-8427-8C70-0202F9483D89}"/>
+                <a16:creationId xmlns:a16="http://schemas.microsoft.com/office/drawing/2014/main" id="{65DECF7F-0FF4-414A-31FA-451974705FA7}"/>
               </a:ext>
             </a:extLst>
           </p:cNvPr>
@@ -453,7 +453,7 @@
           <a:bodyPr/>
           <a:lstStyle/>
           <a:p>
-            <a:fld id="{CCA853AE-2B35-4E40-B8A3-67DBCD9E45C2}" type="datetimeFigureOut">
+            <a:fld id="{47A277B0-1BC8-46D0-96E9-4631C913E98E}" type="datetimeFigureOut">
               <a:rPr lang="en-US" smtClean="0"/>
               <a:t>9/20/2026</a:t>
             </a:fld>
@@ -466,7 +466,7 @@
           <p:cNvPr id="5" name="Footer Placeholder 4">
             <a:extLst>
               <a:ext uri="{FF2B5EF4-FFF2-40B4-BE49-F238E27FC236}">
-                <a16:creationId xmlns:a16="http://schemas.microsoft.com/office/drawing/2014/main" id="{DDAD82E2-D987-62E6-B7C1-F3DAF3CBDD58}"/>
+                <a16:creationId xmlns:a16="http://schemas.microsoft.com/office/drawing/2014/main" id="{6192D71E-30F5-6594-FC90-78ADBB7AB113}"/>
               </a:ext>
             </a:extLst>
           </p:cNvPr>
@@ -491,7 +491,7 @@
           <p:cNvPr id="6" name="Slide Number Placeholder 5">
             <a:extLst>
               <a:ext uri="{FF2B5EF4-FFF2-40B4-BE49-F238E27FC236}">
-                <a16:creationId xmlns:a16="http://schemas.microsoft.com/office/drawing/2014/main" id="{D7E04093-D46D-F4A0-D31C-1B92C85D00FE}"/>
+                <a16:creationId xmlns:a16="http://schemas.microsoft.com/office/drawing/2014/main" id="{2A9F89AD-22AC-2277-3BB3-25491C5342D4}"/>
               </a:ext>
             </a:extLst>
           </p:cNvPr>
@@ -507,7 +507,7 @@
           <a:bodyPr/>
           <a:lstStyle/>
           <a:p>
-            <a:fld id="{B7A613CB-FFFC-4DC9-A6CC-F615930E06AC}" type="slidenum">
+            <a:fld id="{50FEEB4A-BAF6-4C97-B33F-AB910F2FB9EF}" type="slidenum">
               <a:rPr lang="en-US" smtClean="0"/>
               <a:t>‹#›</a:t>
             </a:fld>
@@ -518,7 +518,7 @@
     </p:spTree>
     <p:extLst>
       <p:ext uri="{BB962C8B-B14F-4D97-AF65-F5344CB8AC3E}">
-        <p14:creationId xmlns:p14="http://schemas.microsoft.com/office/powerpoint/2010/main" val="3650742329"/>
+        <p14:creationId xmlns:p14="http://schemas.microsoft.com/office/powerpoint/2010/main" val="396127929"/>
       </p:ext>
     </p:extLst>
   </p:cSld>
@@ -550,7 +550,7 @@
           <p:cNvPr id="2" name="Vertical Title 1">
             <a:extLst>
               <a:ext uri="{FF2B5EF4-FFF2-40B4-BE49-F238E27FC236}">
-                <a16:creationId xmlns:a16="http://schemas.microsoft.com/office/drawing/2014/main" id="{F95B2D6E-7833-ECF2-C6AD-A4513A8A70EB}"/>
+                <a16:creationId xmlns:a16="http://schemas.microsoft.com/office/drawing/2014/main" id="{F7314FD2-7431-AFFA-1D3F-4006F51A578B}"/>
               </a:ext>
             </a:extLst>
           </p:cNvPr>
@@ -583,7 +583,7 @@
           <p:cNvPr id="3" name="Vertical Text Placeholder 2">
             <a:extLst>
               <a:ext uri="{FF2B5EF4-FFF2-40B4-BE49-F238E27FC236}">
-                <a16:creationId xmlns:a16="http://schemas.microsoft.com/office/drawing/2014/main" id="{F3024E64-3D9B-CBF1-489A-56390226CF22}"/>
+                <a16:creationId xmlns:a16="http://schemas.microsoft.com/office/drawing/2014/main" id="{A0AFEA35-90DA-3B86-8C7F-77C6664DAA59}"/>
               </a:ext>
             </a:extLst>
           </p:cNvPr>
@@ -645,7 +645,7 @@
           <p:cNvPr id="4" name="Date Placeholder 3">
             <a:extLst>
               <a:ext uri="{FF2B5EF4-FFF2-40B4-BE49-F238E27FC236}">
-                <a16:creationId xmlns:a16="http://schemas.microsoft.com/office/drawing/2014/main" id="{733B2880-B432-52BA-217B-6971857E6068}"/>
+                <a16:creationId xmlns:a16="http://schemas.microsoft.com/office/drawing/2014/main" id="{AC120847-2620-F189-1A1B-F109ACDB28A6}"/>
               </a:ext>
             </a:extLst>
           </p:cNvPr>
@@ -661,7 +661,7 @@
           <a:bodyPr/>
           <a:lstStyle/>
           <a:p>
-            <a:fld id="{CCA853AE-2B35-4E40-B8A3-67DBCD9E45C2}" type="datetimeFigureOut">
+            <a:fld id="{47A277B0-1BC8-46D0-96E9-4631C913E98E}" type="datetimeFigureOut">
               <a:rPr lang="en-US" smtClean="0"/>
               <a:t>9/20/2026</a:t>
             </a:fld>
@@ -674,7 +674,7 @@
           <p:cNvPr id="5" name="Footer Placeholder 4">
             <a:extLst>
               <a:ext uri="{FF2B5EF4-FFF2-40B4-BE49-F238E27FC236}">
-                <a16:creationId xmlns:a16="http://schemas.microsoft.com/office/drawing/2014/main" id="{50C895CE-C742-0A1C-D16E-6211B02FA923}"/>
+                <a16:creationId xmlns:a16="http://schemas.microsoft.com/office/drawing/2014/main" id="{CAEFF0AA-5C2F-D06C-656F-E3A1E5C3AFF1}"/>
               </a:ext>
             </a:extLst>
           </p:cNvPr>
@@ -699,7 +699,7 @@
           <p:cNvPr id="6" name="Slide Number Placeholder 5">
             <a:extLst>
               <a:ext uri="{FF2B5EF4-FFF2-40B4-BE49-F238E27FC236}">
-                <a16:creationId xmlns:a16="http://schemas.microsoft.com/office/drawing/2014/main" id="{87F1A24E-456A-29E2-8742-72EFD1ED3A11}"/>
+                <a16:creationId xmlns:a16="http://schemas.microsoft.com/office/drawing/2014/main" id="{2E360835-AE83-C673-EC30-862DBDF01511}"/>
               </a:ext>
             </a:extLst>
           </p:cNvPr>
@@ -715,7 +715,7 @@
           <a:bodyPr/>
           <a:lstStyle/>
           <a:p>
-            <a:fld id="{B7A613CB-FFFC-4DC9-A6CC-F615930E06AC}" type="slidenum">
+            <a:fld id="{50FEEB4A-BAF6-4C97-B33F-AB910F2FB9EF}" type="slidenum">
               <a:rPr lang="en-US" smtClean="0"/>
               <a:t>‹#›</a:t>
             </a:fld>
@@ -726,7 +726,7 @@
     </p:spTree>
     <p:extLst>
       <p:ext uri="{BB962C8B-B14F-4D97-AF65-F5344CB8AC3E}">
-        <p14:creationId xmlns:p14="http://schemas.microsoft.com/office/powerpoint/2010/main" val="1060626185"/>
+        <p14:creationId xmlns:p14="http://schemas.microsoft.com/office/powerpoint/2010/main" val="3252417236"/>
       </p:ext>
     </p:extLst>
   </p:cSld>
@@ -758,7 +758,7 @@
           <p:cNvPr id="2" name="Title 1">
             <a:extLst>
               <a:ext uri="{FF2B5EF4-FFF2-40B4-BE49-F238E27FC236}">
-                <a16:creationId xmlns:a16="http://schemas.microsoft.com/office/drawing/2014/main" id="{AFCADFC3-048A-20D5-9ED5-B158DF4ADE05}"/>
+                <a16:creationId xmlns:a16="http://schemas.microsoft.com/office/drawing/2014/main" id="{48D2D2DC-82A1-B6CB-1547-1E58439CA708}"/>
               </a:ext>
             </a:extLst>
           </p:cNvPr>
@@ -786,7 +786,7 @@
           <p:cNvPr id="3" name="Content Placeholder 2">
             <a:extLst>
               <a:ext uri="{FF2B5EF4-FFF2-40B4-BE49-F238E27FC236}">
-                <a16:creationId xmlns:a16="http://schemas.microsoft.com/office/drawing/2014/main" id="{BC483BEA-0AA0-1B02-8027-281CCB23AB68}"/>
+                <a16:creationId xmlns:a16="http://schemas.microsoft.com/office/drawing/2014/main" id="{D7C29635-79C5-3F98-0776-0CDB2DDF83F2}"/>
               </a:ext>
             </a:extLst>
           </p:cNvPr>
@@ -843,7 +843,7 @@
           <p:cNvPr id="4" name="Date Placeholder 3">
             <a:extLst>
               <a:ext uri="{FF2B5EF4-FFF2-40B4-BE49-F238E27FC236}">
-                <a16:creationId xmlns:a16="http://schemas.microsoft.com/office/drawing/2014/main" id="{5B2E9597-6FD4-00A7-2ACE-A734087DA64F}"/>
+                <a16:creationId xmlns:a16="http://schemas.microsoft.com/office/drawing/2014/main" id="{568A0E80-EA35-8126-CB1B-BE90DE1FA20E}"/>
               </a:ext>
             </a:extLst>
           </p:cNvPr>
@@ -859,7 +859,7 @@
           <a:bodyPr/>
           <a:lstStyle/>
           <a:p>
-            <a:fld id="{CCA853AE-2B35-4E40-B8A3-67DBCD9E45C2}" type="datetimeFigureOut">
+            <a:fld id="{47A277B0-1BC8-46D0-96E9-4631C913E98E}" type="datetimeFigureOut">
               <a:rPr lang="en-US" smtClean="0"/>
               <a:t>9/20/2026</a:t>
             </a:fld>
@@ -872,7 +872,7 @@
           <p:cNvPr id="5" name="Footer Placeholder 4">
             <a:extLst>
               <a:ext uri="{FF2B5EF4-FFF2-40B4-BE49-F238E27FC236}">
-                <a16:creationId xmlns:a16="http://schemas.microsoft.com/office/drawing/2014/main" id="{16334E67-1D00-E523-8806-EF49ACF59AA9}"/>
+                <a16:creationId xmlns:a16="http://schemas.microsoft.com/office/drawing/2014/main" id="{30251070-4914-3546-4A93-9C452E47CF2C}"/>
               </a:ext>
             </a:extLst>
           </p:cNvPr>
@@ -897,7 +897,7 @@
           <p:cNvPr id="6" name="Slide Number Placeholder 5">
             <a:extLst>
               <a:ext uri="{FF2B5EF4-FFF2-40B4-BE49-F238E27FC236}">
-                <a16:creationId xmlns:a16="http://schemas.microsoft.com/office/drawing/2014/main" id="{A405F66E-D132-F0F4-E120-DB095D215F6C}"/>
+                <a16:creationId xmlns:a16="http://schemas.microsoft.com/office/drawing/2014/main" id="{D1795C04-9657-4BB9-1854-19550E3EB5F1}"/>
               </a:ext>
             </a:extLst>
           </p:cNvPr>
@@ -913,7 +913,7 @@
           <a:bodyPr/>
           <a:lstStyle/>
           <a:p>
-            <a:fld id="{B7A613CB-FFFC-4DC9-A6CC-F615930E06AC}" type="slidenum">
+            <a:fld id="{50FEEB4A-BAF6-4C97-B33F-AB910F2FB9EF}" type="slidenum">
               <a:rPr lang="en-US" smtClean="0"/>
               <a:t>‹#›</a:t>
             </a:fld>
@@ -924,7 +924,7 @@
     </p:spTree>
     <p:extLst>
       <p:ext uri="{BB962C8B-B14F-4D97-AF65-F5344CB8AC3E}">
-        <p14:creationId xmlns:p14="http://schemas.microsoft.com/office/powerpoint/2010/main" val="2664063682"/>
+        <p14:creationId xmlns:p14="http://schemas.microsoft.com/office/powerpoint/2010/main" val="142112577"/>
       </p:ext>
     </p:extLst>
   </p:cSld>
@@ -956,7 +956,7 @@
           <p:cNvPr id="2" name="Title 1">
             <a:extLst>
               <a:ext uri="{FF2B5EF4-FFF2-40B4-BE49-F238E27FC236}">
-                <a16:creationId xmlns:a16="http://schemas.microsoft.com/office/drawing/2014/main" id="{E6EBA1A8-A7AA-0A31-2F49-2774C81F2033}"/>
+                <a16:creationId xmlns:a16="http://schemas.microsoft.com/office/drawing/2014/main" id="{67531E01-A015-BC94-A192-D318757B2573}"/>
               </a:ext>
             </a:extLst>
           </p:cNvPr>
@@ -993,7 +993,7 @@
           <p:cNvPr id="3" name="Text Placeholder 2">
             <a:extLst>
               <a:ext uri="{FF2B5EF4-FFF2-40B4-BE49-F238E27FC236}">
-                <a16:creationId xmlns:a16="http://schemas.microsoft.com/office/drawing/2014/main" id="{FED624A8-4B9D-52B8-0667-8326653DAE1D}"/>
+                <a16:creationId xmlns:a16="http://schemas.microsoft.com/office/drawing/2014/main" id="{FE01FF7A-2C95-033D-A756-76D57645F875}"/>
               </a:ext>
             </a:extLst>
           </p:cNvPr>
@@ -1118,7 +1118,7 @@
           <p:cNvPr id="4" name="Date Placeholder 3">
             <a:extLst>
               <a:ext uri="{FF2B5EF4-FFF2-40B4-BE49-F238E27FC236}">
-                <a16:creationId xmlns:a16="http://schemas.microsoft.com/office/drawing/2014/main" id="{72731B36-6798-2E81-47F4-0A602D834061}"/>
+                <a16:creationId xmlns:a16="http://schemas.microsoft.com/office/drawing/2014/main" id="{962C643C-913B-2314-7D33-417F446D3EBA}"/>
               </a:ext>
             </a:extLst>
           </p:cNvPr>
@@ -1134,7 +1134,7 @@
           <a:bodyPr/>
           <a:lstStyle/>
           <a:p>
-            <a:fld id="{CCA853AE-2B35-4E40-B8A3-67DBCD9E45C2}" type="datetimeFigureOut">
+            <a:fld id="{47A277B0-1BC8-46D0-96E9-4631C913E98E}" type="datetimeFigureOut">
               <a:rPr lang="en-US" smtClean="0"/>
               <a:t>9/20/2026</a:t>
             </a:fld>
@@ -1147,7 +1147,7 @@
           <p:cNvPr id="5" name="Footer Placeholder 4">
             <a:extLst>
               <a:ext uri="{FF2B5EF4-FFF2-40B4-BE49-F238E27FC236}">
-                <a16:creationId xmlns:a16="http://schemas.microsoft.com/office/drawing/2014/main" id="{DC613093-ABD3-D94F-9FA5-4F8952416678}"/>
+                <a16:creationId xmlns:a16="http://schemas.microsoft.com/office/drawing/2014/main" id="{B9ACF086-D2A3-07EA-9683-18732ACE2B79}"/>
               </a:ext>
             </a:extLst>
           </p:cNvPr>
@@ -1172,7 +1172,7 @@
           <p:cNvPr id="6" name="Slide Number Placeholder 5">
             <a:extLst>
               <a:ext uri="{FF2B5EF4-FFF2-40B4-BE49-F238E27FC236}">
-                <a16:creationId xmlns:a16="http://schemas.microsoft.com/office/drawing/2014/main" id="{F638748E-2D85-EC6A-0526-F14EA5829A63}"/>
+                <a16:creationId xmlns:a16="http://schemas.microsoft.com/office/drawing/2014/main" id="{23B44AF3-79B6-5752-9546-52B244136A00}"/>
               </a:ext>
             </a:extLst>
           </p:cNvPr>
@@ -1188,7 +1188,7 @@
           <a:bodyPr/>
           <a:lstStyle/>
           <a:p>
-            <a:fld id="{B7A613CB-FFFC-4DC9-A6CC-F615930E06AC}" type="slidenum">
+            <a:fld id="{50FEEB4A-BAF6-4C97-B33F-AB910F2FB9EF}" type="slidenum">
               <a:rPr lang="en-US" smtClean="0"/>
               <a:t>‹#›</a:t>
             </a:fld>
@@ -1199,7 +1199,7 @@
     </p:spTree>
     <p:extLst>
       <p:ext uri="{BB962C8B-B14F-4D97-AF65-F5344CB8AC3E}">
-        <p14:creationId xmlns:p14="http://schemas.microsoft.com/office/powerpoint/2010/main" val="2624267196"/>
+        <p14:creationId xmlns:p14="http://schemas.microsoft.com/office/powerpoint/2010/main" val="655762172"/>
       </p:ext>
     </p:extLst>
   </p:cSld>
@@ -1231,7 +1231,7 @@
           <p:cNvPr id="2" name="Title 1">
             <a:extLst>
               <a:ext uri="{FF2B5EF4-FFF2-40B4-BE49-F238E27FC236}">
-                <a16:creationId xmlns:a16="http://schemas.microsoft.com/office/drawing/2014/main" id="{41D75147-B3DC-43E4-F015-91C252E6EDB7}"/>
+                <a16:creationId xmlns:a16="http://schemas.microsoft.com/office/drawing/2014/main" id="{A6BC012A-E2B5-D268-7850-08C6B63201EB}"/>
               </a:ext>
             </a:extLst>
           </p:cNvPr>
@@ -1259,7 +1259,7 @@
           <p:cNvPr id="3" name="Content Placeholder 2">
             <a:extLst>
               <a:ext uri="{FF2B5EF4-FFF2-40B4-BE49-F238E27FC236}">
-                <a16:creationId xmlns:a16="http://schemas.microsoft.com/office/drawing/2014/main" id="{FB31DF8C-F369-ABD2-4810-0DEEF444AB24}"/>
+                <a16:creationId xmlns:a16="http://schemas.microsoft.com/office/drawing/2014/main" id="{21B5E80F-F993-C9F7-EF97-423A8562FE6B}"/>
               </a:ext>
             </a:extLst>
           </p:cNvPr>
@@ -1321,7 +1321,7 @@
           <p:cNvPr id="4" name="Content Placeholder 3">
             <a:extLst>
               <a:ext uri="{FF2B5EF4-FFF2-40B4-BE49-F238E27FC236}">
-                <a16:creationId xmlns:a16="http://schemas.microsoft.com/office/drawing/2014/main" id="{1CB7000F-B796-2199-8FCA-8D0FC3C62D80}"/>
+                <a16:creationId xmlns:a16="http://schemas.microsoft.com/office/drawing/2014/main" id="{3558C8E3-0847-5D8F-6DB9-480D8D39D0AF}"/>
               </a:ext>
             </a:extLst>
           </p:cNvPr>
@@ -1383,7 +1383,7 @@
           <p:cNvPr id="5" name="Date Placeholder 4">
             <a:extLst>
               <a:ext uri="{FF2B5EF4-FFF2-40B4-BE49-F238E27FC236}">
-                <a16:creationId xmlns:a16="http://schemas.microsoft.com/office/drawing/2014/main" id="{F21BAD2A-75B0-0237-9E80-618643EB0067}"/>
+                <a16:creationId xmlns:a16="http://schemas.microsoft.com/office/drawing/2014/main" id="{01386895-B809-60B5-E242-11B7829582F5}"/>
               </a:ext>
             </a:extLst>
           </p:cNvPr>
@@ -1399,7 +1399,7 @@
           <a:bodyPr/>
           <a:lstStyle/>
           <a:p>
-            <a:fld id="{CCA853AE-2B35-4E40-B8A3-67DBCD9E45C2}" type="datetimeFigureOut">
+            <a:fld id="{47A277B0-1BC8-46D0-96E9-4631C913E98E}" type="datetimeFigureOut">
               <a:rPr lang="en-US" smtClean="0"/>
               <a:t>9/20/2026</a:t>
             </a:fld>
@@ -1412,7 +1412,7 @@
           <p:cNvPr id="6" name="Footer Placeholder 5">
             <a:extLst>
               <a:ext uri="{FF2B5EF4-FFF2-40B4-BE49-F238E27FC236}">
-                <a16:creationId xmlns:a16="http://schemas.microsoft.com/office/drawing/2014/main" id="{DDF2C0B3-DCE1-3B9A-BD15-B5C52B09E6AA}"/>
+                <a16:creationId xmlns:a16="http://schemas.microsoft.com/office/drawing/2014/main" id="{C425E985-BE88-D45F-7F9D-EDF332EC59D0}"/>
               </a:ext>
             </a:extLst>
           </p:cNvPr>
@@ -1437,7 +1437,7 @@
           <p:cNvPr id="7" name="Slide Number Placeholder 6">
             <a:extLst>
               <a:ext uri="{FF2B5EF4-FFF2-40B4-BE49-F238E27FC236}">
-                <a16:creationId xmlns:a16="http://schemas.microsoft.com/office/drawing/2014/main" id="{7A1CB0C6-9577-291E-2906-172025F15293}"/>
+                <a16:creationId xmlns:a16="http://schemas.microsoft.com/office/drawing/2014/main" id="{62C86C2A-FD40-27D0-D915-D67227C2918F}"/>
               </a:ext>
             </a:extLst>
           </p:cNvPr>
@@ -1453,7 +1453,7 @@
           <a:bodyPr/>
           <a:lstStyle/>
           <a:p>
-            <a:fld id="{B7A613CB-FFFC-4DC9-A6CC-F615930E06AC}" type="slidenum">
+            <a:fld id="{50FEEB4A-BAF6-4C97-B33F-AB910F2FB9EF}" type="slidenum">
               <a:rPr lang="en-US" smtClean="0"/>
               <a:t>‹#›</a:t>
             </a:fld>
@@ -1464,7 +1464,7 @@
     </p:spTree>
     <p:extLst>
       <p:ext uri="{BB962C8B-B14F-4D97-AF65-F5344CB8AC3E}">
-        <p14:creationId xmlns:p14="http://schemas.microsoft.com/office/powerpoint/2010/main" val="2624155643"/>
+        <p14:creationId xmlns:p14="http://schemas.microsoft.com/office/powerpoint/2010/main" val="1376151484"/>
       </p:ext>
     </p:extLst>
   </p:cSld>
@@ -1496,7 +1496,7 @@
           <p:cNvPr id="2" name="Title 1">
             <a:extLst>
               <a:ext uri="{FF2B5EF4-FFF2-40B4-BE49-F238E27FC236}">
-                <a16:creationId xmlns:a16="http://schemas.microsoft.com/office/drawing/2014/main" id="{BE7D7C01-E83A-0DF9-EB44-D85618083DF9}"/>
+                <a16:creationId xmlns:a16="http://schemas.microsoft.com/office/drawing/2014/main" id="{276719F4-BBBD-24EC-15D8-66E53FECDAE6}"/>
               </a:ext>
             </a:extLst>
           </p:cNvPr>
@@ -1529,7 +1529,7 @@
           <p:cNvPr id="3" name="Text Placeholder 2">
             <a:extLst>
               <a:ext uri="{FF2B5EF4-FFF2-40B4-BE49-F238E27FC236}">
-                <a16:creationId xmlns:a16="http://schemas.microsoft.com/office/drawing/2014/main" id="{02A20591-9BA2-46B2-2052-8B95BB825357}"/>
+                <a16:creationId xmlns:a16="http://schemas.microsoft.com/office/drawing/2014/main" id="{89BF20CB-C19E-3DC1-3A96-F6EE01BA9974}"/>
               </a:ext>
             </a:extLst>
           </p:cNvPr>
@@ -1600,7 +1600,7 @@
           <p:cNvPr id="4" name="Content Placeholder 3">
             <a:extLst>
               <a:ext uri="{FF2B5EF4-FFF2-40B4-BE49-F238E27FC236}">
-                <a16:creationId xmlns:a16="http://schemas.microsoft.com/office/drawing/2014/main" id="{2AB80D05-1ECA-09B3-4C52-47932EC90017}"/>
+                <a16:creationId xmlns:a16="http://schemas.microsoft.com/office/drawing/2014/main" id="{A11C17E1-C2F9-7C88-E4A6-CE3B2A58AE0A}"/>
               </a:ext>
             </a:extLst>
           </p:cNvPr>
@@ -1662,7 +1662,7 @@
           <p:cNvPr id="5" name="Text Placeholder 4">
             <a:extLst>
               <a:ext uri="{FF2B5EF4-FFF2-40B4-BE49-F238E27FC236}">
-                <a16:creationId xmlns:a16="http://schemas.microsoft.com/office/drawing/2014/main" id="{B894F3E5-D819-A33D-9268-A2AA04AF45DD}"/>
+                <a16:creationId xmlns:a16="http://schemas.microsoft.com/office/drawing/2014/main" id="{F518FA84-1A8F-5660-3607-66F76F54117D}"/>
               </a:ext>
             </a:extLst>
           </p:cNvPr>
@@ -1733,7 +1733,7 @@
           <p:cNvPr id="6" name="Content Placeholder 5">
             <a:extLst>
               <a:ext uri="{FF2B5EF4-FFF2-40B4-BE49-F238E27FC236}">
-                <a16:creationId xmlns:a16="http://schemas.microsoft.com/office/drawing/2014/main" id="{4C881185-46B6-91DF-D2BC-DDA53F20AC55}"/>
+                <a16:creationId xmlns:a16="http://schemas.microsoft.com/office/drawing/2014/main" id="{9166DE40-6C1E-88E1-AEC4-B099C96A0121}"/>
               </a:ext>
             </a:extLst>
           </p:cNvPr>
@@ -1795,7 +1795,7 @@
           <p:cNvPr id="7" name="Date Placeholder 6">
             <a:extLst>
               <a:ext uri="{FF2B5EF4-FFF2-40B4-BE49-F238E27FC236}">
-                <a16:creationId xmlns:a16="http://schemas.microsoft.com/office/drawing/2014/main" id="{2BE8EDC0-7782-DB1C-9346-D3DE8F4A907E}"/>
+                <a16:creationId xmlns:a16="http://schemas.microsoft.com/office/drawing/2014/main" id="{EC623550-B7B6-A11F-5BB7-60CB081B455C}"/>
               </a:ext>
             </a:extLst>
           </p:cNvPr>
@@ -1811,7 +1811,7 @@
           <a:bodyPr/>
           <a:lstStyle/>
           <a:p>
-            <a:fld id="{CCA853AE-2B35-4E40-B8A3-67DBCD9E45C2}" type="datetimeFigureOut">
+            <a:fld id="{47A277B0-1BC8-46D0-96E9-4631C913E98E}" type="datetimeFigureOut">
               <a:rPr lang="en-US" smtClean="0"/>
               <a:t>9/20/2026</a:t>
             </a:fld>
@@ -1824,7 +1824,7 @@
           <p:cNvPr id="8" name="Footer Placeholder 7">
             <a:extLst>
               <a:ext uri="{FF2B5EF4-FFF2-40B4-BE49-F238E27FC236}">
-                <a16:creationId xmlns:a16="http://schemas.microsoft.com/office/drawing/2014/main" id="{8AE23666-3A53-D2D0-5A80-2D1CA48127F9}"/>
+                <a16:creationId xmlns:a16="http://schemas.microsoft.com/office/drawing/2014/main" id="{75602C6E-71F9-06DB-938D-D27D693683A6}"/>
               </a:ext>
             </a:extLst>
           </p:cNvPr>
@@ -1849,7 +1849,7 @@
           <p:cNvPr id="9" name="Slide Number Placeholder 8">
             <a:extLst>
               <a:ext uri="{FF2B5EF4-FFF2-40B4-BE49-F238E27FC236}">
-                <a16:creationId xmlns:a16="http://schemas.microsoft.com/office/drawing/2014/main" id="{999B0599-B6E0-1898-1411-A0A94BD53C68}"/>
+                <a16:creationId xmlns:a16="http://schemas.microsoft.com/office/drawing/2014/main" id="{4B2A649B-DCA6-3573-92FE-825F9E848D20}"/>
               </a:ext>
             </a:extLst>
           </p:cNvPr>
@@ -1865,7 +1865,7 @@
           <a:bodyPr/>
           <a:lstStyle/>
           <a:p>
-            <a:fld id="{B7A613CB-FFFC-4DC9-A6CC-F615930E06AC}" type="slidenum">
+            <a:fld id="{50FEEB4A-BAF6-4C97-B33F-AB910F2FB9EF}" type="slidenum">
               <a:rPr lang="en-US" smtClean="0"/>
               <a:t>‹#›</a:t>
             </a:fld>
@@ -1876,7 +1876,7 @@
     </p:spTree>
     <p:extLst>
       <p:ext uri="{BB962C8B-B14F-4D97-AF65-F5344CB8AC3E}">
-        <p14:creationId xmlns:p14="http://schemas.microsoft.com/office/powerpoint/2010/main" val="990608582"/>
+        <p14:creationId xmlns:p14="http://schemas.microsoft.com/office/powerpoint/2010/main" val="1994951457"/>
       </p:ext>
     </p:extLst>
   </p:cSld>
@@ -1908,7 +1908,7 @@
           <p:cNvPr id="2" name="Title 1">
             <a:extLst>
               <a:ext uri="{FF2B5EF4-FFF2-40B4-BE49-F238E27FC236}">
-                <a16:creationId xmlns:a16="http://schemas.microsoft.com/office/drawing/2014/main" id="{2E5BAC87-23D9-2A72-83FB-3F2746812CE1}"/>
+                <a16:creationId xmlns:a16="http://schemas.microsoft.com/office/drawing/2014/main" id="{0CEDC625-5B0F-0833-4F56-2DCE9CBB328D}"/>
               </a:ext>
             </a:extLst>
           </p:cNvPr>
@@ -1936,7 +1936,7 @@
           <p:cNvPr id="3" name="Date Placeholder 2">
             <a:extLst>
               <a:ext uri="{FF2B5EF4-FFF2-40B4-BE49-F238E27FC236}">
-                <a16:creationId xmlns:a16="http://schemas.microsoft.com/office/drawing/2014/main" id="{9C37C56C-57CE-C074-2CEC-64FB80D884D8}"/>
+                <a16:creationId xmlns:a16="http://schemas.microsoft.com/office/drawing/2014/main" id="{3A815A64-59CA-C67C-BA00-598F9C4E5573}"/>
               </a:ext>
             </a:extLst>
           </p:cNvPr>
@@ -1952,7 +1952,7 @@
           <a:bodyPr/>
           <a:lstStyle/>
           <a:p>
-            <a:fld id="{CCA853AE-2B35-4E40-B8A3-67DBCD9E45C2}" type="datetimeFigureOut">
+            <a:fld id="{47A277B0-1BC8-46D0-96E9-4631C913E98E}" type="datetimeFigureOut">
               <a:rPr lang="en-US" smtClean="0"/>
               <a:t>9/20/2026</a:t>
             </a:fld>
@@ -1965,7 +1965,7 @@
           <p:cNvPr id="4" name="Footer Placeholder 3">
             <a:extLst>
               <a:ext uri="{FF2B5EF4-FFF2-40B4-BE49-F238E27FC236}">
-                <a16:creationId xmlns:a16="http://schemas.microsoft.com/office/drawing/2014/main" id="{86124FF3-AE8A-965B-D741-466F511561AD}"/>
+                <a16:creationId xmlns:a16="http://schemas.microsoft.com/office/drawing/2014/main" id="{E6CD03BC-F4CD-873C-EB90-87A886F6ADCC}"/>
               </a:ext>
             </a:extLst>
           </p:cNvPr>
@@ -1990,7 +1990,7 @@
           <p:cNvPr id="5" name="Slide Number Placeholder 4">
             <a:extLst>
               <a:ext uri="{FF2B5EF4-FFF2-40B4-BE49-F238E27FC236}">
-                <a16:creationId xmlns:a16="http://schemas.microsoft.com/office/drawing/2014/main" id="{8DC88BDF-34B2-FBD6-31A1-D55848CD9712}"/>
+                <a16:creationId xmlns:a16="http://schemas.microsoft.com/office/drawing/2014/main" id="{4F293582-2F2C-3A14-CC28-9969A70A7329}"/>
               </a:ext>
             </a:extLst>
           </p:cNvPr>
@@ -2006,7 +2006,7 @@
           <a:bodyPr/>
           <a:lstStyle/>
           <a:p>
-            <a:fld id="{B7A613CB-FFFC-4DC9-A6CC-F615930E06AC}" type="slidenum">
+            <a:fld id="{50FEEB4A-BAF6-4C97-B33F-AB910F2FB9EF}" type="slidenum">
               <a:rPr lang="en-US" smtClean="0"/>
               <a:t>‹#›</a:t>
             </a:fld>
@@ -2017,7 +2017,7 @@
     </p:spTree>
     <p:extLst>
       <p:ext uri="{BB962C8B-B14F-4D97-AF65-F5344CB8AC3E}">
-        <p14:creationId xmlns:p14="http://schemas.microsoft.com/office/powerpoint/2010/main" val="1751147494"/>
+        <p14:creationId xmlns:p14="http://schemas.microsoft.com/office/powerpoint/2010/main" val="4192399386"/>
       </p:ext>
     </p:extLst>
   </p:cSld>
@@ -2049,7 +2049,7 @@
           <p:cNvPr id="2" name="Date Placeholder 1">
             <a:extLst>
               <a:ext uri="{FF2B5EF4-FFF2-40B4-BE49-F238E27FC236}">
-                <a16:creationId xmlns:a16="http://schemas.microsoft.com/office/drawing/2014/main" id="{2E66FB6E-9E4A-35F2-964D-EB6A7C4FA14C}"/>
+                <a16:creationId xmlns:a16="http://schemas.microsoft.com/office/drawing/2014/main" id="{3A2AF5A6-0F23-5465-737C-F57614E00CA7}"/>
               </a:ext>
             </a:extLst>
           </p:cNvPr>
@@ -2065,7 +2065,7 @@
           <a:bodyPr/>
           <a:lstStyle/>
           <a:p>
-            <a:fld id="{CCA853AE-2B35-4E40-B8A3-67DBCD9E45C2}" type="datetimeFigureOut">
+            <a:fld id="{47A277B0-1BC8-46D0-96E9-4631C913E98E}" type="datetimeFigureOut">
               <a:rPr lang="en-US" smtClean="0"/>
               <a:t>9/20/2026</a:t>
             </a:fld>
@@ -2078,7 +2078,7 @@
           <p:cNvPr id="3" name="Footer Placeholder 2">
             <a:extLst>
               <a:ext uri="{FF2B5EF4-FFF2-40B4-BE49-F238E27FC236}">
-                <a16:creationId xmlns:a16="http://schemas.microsoft.com/office/drawing/2014/main" id="{12AD456D-E32C-D76F-5C7D-E22673E7D86B}"/>
+                <a16:creationId xmlns:a16="http://schemas.microsoft.com/office/drawing/2014/main" id="{B1C5CE3A-462F-EA71-543F-BB2524A256E8}"/>
               </a:ext>
             </a:extLst>
           </p:cNvPr>
@@ -2103,7 +2103,7 @@
           <p:cNvPr id="4" name="Slide Number Placeholder 3">
             <a:extLst>
               <a:ext uri="{FF2B5EF4-FFF2-40B4-BE49-F238E27FC236}">
-                <a16:creationId xmlns:a16="http://schemas.microsoft.com/office/drawing/2014/main" id="{19CC3742-93B3-E823-23DC-ED7AD7FB721F}"/>
+                <a16:creationId xmlns:a16="http://schemas.microsoft.com/office/drawing/2014/main" id="{3BEF2267-0BCA-5B0B-3B33-706EBD8B6F53}"/>
               </a:ext>
             </a:extLst>
           </p:cNvPr>
@@ -2119,7 +2119,7 @@
           <a:bodyPr/>
           <a:lstStyle/>
           <a:p>
-            <a:fld id="{B7A613CB-FFFC-4DC9-A6CC-F615930E06AC}" type="slidenum">
+            <a:fld id="{50FEEB4A-BAF6-4C97-B33F-AB910F2FB9EF}" type="slidenum">
               <a:rPr lang="en-US" smtClean="0"/>
               <a:t>‹#›</a:t>
             </a:fld>
@@ -2130,7 +2130,7 @@
     </p:spTree>
     <p:extLst>
       <p:ext uri="{BB962C8B-B14F-4D97-AF65-F5344CB8AC3E}">
-        <p14:creationId xmlns:p14="http://schemas.microsoft.com/office/powerpoint/2010/main" val="106827487"/>
+        <p14:creationId xmlns:p14="http://schemas.microsoft.com/office/powerpoint/2010/main" val="3403627975"/>
       </p:ext>
     </p:extLst>
   </p:cSld>
@@ -2162,7 +2162,7 @@
           <p:cNvPr id="2" name="Title 1">
             <a:extLst>
               <a:ext uri="{FF2B5EF4-FFF2-40B4-BE49-F238E27FC236}">
-                <a16:creationId xmlns:a16="http://schemas.microsoft.com/office/drawing/2014/main" id="{3D00E818-C964-02A6-8BAF-137F02F61B67}"/>
+                <a16:creationId xmlns:a16="http://schemas.microsoft.com/office/drawing/2014/main" id="{70F40766-0CE5-6BD2-8171-AED8DA423575}"/>
               </a:ext>
             </a:extLst>
           </p:cNvPr>
@@ -2199,7 +2199,7 @@
           <p:cNvPr id="3" name="Content Placeholder 2">
             <a:extLst>
               <a:ext uri="{FF2B5EF4-FFF2-40B4-BE49-F238E27FC236}">
-                <a16:creationId xmlns:a16="http://schemas.microsoft.com/office/drawing/2014/main" id="{F7353BA2-049D-567B-A57C-DC04A0E077EE}"/>
+                <a16:creationId xmlns:a16="http://schemas.microsoft.com/office/drawing/2014/main" id="{7BEC6721-936F-8430-BDE2-DBBB51052BB4}"/>
               </a:ext>
             </a:extLst>
           </p:cNvPr>
@@ -2289,7 +2289,7 @@
           <p:cNvPr id="4" name="Text Placeholder 3">
             <a:extLst>
               <a:ext uri="{FF2B5EF4-FFF2-40B4-BE49-F238E27FC236}">
-                <a16:creationId xmlns:a16="http://schemas.microsoft.com/office/drawing/2014/main" id="{61858A85-3433-095B-A8DF-E1AC65955136}"/>
+                <a16:creationId xmlns:a16="http://schemas.microsoft.com/office/drawing/2014/main" id="{2977A5DE-C780-B05E-FD9C-A08C7CED77B0}"/>
               </a:ext>
             </a:extLst>
           </p:cNvPr>
@@ -2360,7 +2360,7 @@
           <p:cNvPr id="5" name="Date Placeholder 4">
             <a:extLst>
               <a:ext uri="{FF2B5EF4-FFF2-40B4-BE49-F238E27FC236}">
-                <a16:creationId xmlns:a16="http://schemas.microsoft.com/office/drawing/2014/main" id="{B4626658-3318-FE10-8D1A-AF14D968D7A1}"/>
+                <a16:creationId xmlns:a16="http://schemas.microsoft.com/office/drawing/2014/main" id="{A95E13AF-A7BB-D2E4-342C-B1B51E98DF3D}"/>
               </a:ext>
             </a:extLst>
           </p:cNvPr>
@@ -2376,7 +2376,7 @@
           <a:bodyPr/>
           <a:lstStyle/>
           <a:p>
-            <a:fld id="{CCA853AE-2B35-4E40-B8A3-67DBCD9E45C2}" type="datetimeFigureOut">
+            <a:fld id="{47A277B0-1BC8-46D0-96E9-4631C913E98E}" type="datetimeFigureOut">
               <a:rPr lang="en-US" smtClean="0"/>
               <a:t>9/20/2026</a:t>
             </a:fld>
@@ -2389,7 +2389,7 @@
           <p:cNvPr id="6" name="Footer Placeholder 5">
             <a:extLst>
               <a:ext uri="{FF2B5EF4-FFF2-40B4-BE49-F238E27FC236}">
-                <a16:creationId xmlns:a16="http://schemas.microsoft.com/office/drawing/2014/main" id="{7AC67B67-192E-0972-464C-D6B69EE7B45F}"/>
+                <a16:creationId xmlns:a16="http://schemas.microsoft.com/office/drawing/2014/main" id="{174D0000-C9E9-B0B9-43FB-AFEAB48C0BAE}"/>
               </a:ext>
             </a:extLst>
           </p:cNvPr>
@@ -2414,7 +2414,7 @@
           <p:cNvPr id="7" name="Slide Number Placeholder 6">
             <a:extLst>
               <a:ext uri="{FF2B5EF4-FFF2-40B4-BE49-F238E27FC236}">
-                <a16:creationId xmlns:a16="http://schemas.microsoft.com/office/drawing/2014/main" id="{76B1C0B3-2A0D-670F-5115-31A456B790D1}"/>
+                <a16:creationId xmlns:a16="http://schemas.microsoft.com/office/drawing/2014/main" id="{58DD9398-9A84-CD3D-E896-3E6CD792A205}"/>
               </a:ext>
             </a:extLst>
           </p:cNvPr>
@@ -2430,7 +2430,7 @@
           <a:bodyPr/>
           <a:lstStyle/>
           <a:p>
-            <a:fld id="{B7A613CB-FFFC-4DC9-A6CC-F615930E06AC}" type="slidenum">
+            <a:fld id="{50FEEB4A-BAF6-4C97-B33F-AB910F2FB9EF}" type="slidenum">
               <a:rPr lang="en-US" smtClean="0"/>
               <a:t>‹#›</a:t>
             </a:fld>
@@ -2441,7 +2441,7 @@
     </p:spTree>
     <p:extLst>
       <p:ext uri="{BB962C8B-B14F-4D97-AF65-F5344CB8AC3E}">
-        <p14:creationId xmlns:p14="http://schemas.microsoft.com/office/powerpoint/2010/main" val="3987854724"/>
+        <p14:creationId xmlns:p14="http://schemas.microsoft.com/office/powerpoint/2010/main" val="3722359309"/>
       </p:ext>
     </p:extLst>
   </p:cSld>
@@ -2473,7 +2473,7 @@
           <p:cNvPr id="2" name="Title 1">
             <a:extLst>
               <a:ext uri="{FF2B5EF4-FFF2-40B4-BE49-F238E27FC236}">
-                <a16:creationId xmlns:a16="http://schemas.microsoft.com/office/drawing/2014/main" id="{68ABF129-5DE6-29E2-D196-FF9D288AD131}"/>
+                <a16:creationId xmlns:a16="http://schemas.microsoft.com/office/drawing/2014/main" id="{FC8FF4C1-CAF9-5580-DC46-62E8480D0568}"/>
               </a:ext>
             </a:extLst>
           </p:cNvPr>
@@ -2510,7 +2510,7 @@
           <p:cNvPr id="3" name="Picture Placeholder 2">
             <a:extLst>
               <a:ext uri="{FF2B5EF4-FFF2-40B4-BE49-F238E27FC236}">
-                <a16:creationId xmlns:a16="http://schemas.microsoft.com/office/drawing/2014/main" id="{DCF01FD9-AC15-793D-63AB-BD5BA67C066D}"/>
+                <a16:creationId xmlns:a16="http://schemas.microsoft.com/office/drawing/2014/main" id="{5736FD75-C1BA-229F-42CE-B9B68A3BC78E}"/>
               </a:ext>
             </a:extLst>
           </p:cNvPr>
@@ -2577,7 +2577,7 @@
           <p:cNvPr id="4" name="Text Placeholder 3">
             <a:extLst>
               <a:ext uri="{FF2B5EF4-FFF2-40B4-BE49-F238E27FC236}">
-                <a16:creationId xmlns:a16="http://schemas.microsoft.com/office/drawing/2014/main" id="{861B8FF1-15AA-8EF6-803D-190E25DF24CA}"/>
+                <a16:creationId xmlns:a16="http://schemas.microsoft.com/office/drawing/2014/main" id="{C12F13C0-3584-0B79-A3F1-7655E28BBACF}"/>
               </a:ext>
             </a:extLst>
           </p:cNvPr>
@@ -2648,7 +2648,7 @@
           <p:cNvPr id="5" name="Date Placeholder 4">
             <a:extLst>
               <a:ext uri="{FF2B5EF4-FFF2-40B4-BE49-F238E27FC236}">
-                <a16:creationId xmlns:a16="http://schemas.microsoft.com/office/drawing/2014/main" id="{517AD02A-FE62-3DD5-4B7A-5FDA3999AC65}"/>
+                <a16:creationId xmlns:a16="http://schemas.microsoft.com/office/drawing/2014/main" id="{1BBC652C-A6A7-0552-13F6-6887908DFF58}"/>
               </a:ext>
             </a:extLst>
           </p:cNvPr>
@@ -2664,7 +2664,7 @@
           <a:bodyPr/>
           <a:lstStyle/>
           <a:p>
-            <a:fld id="{CCA853AE-2B35-4E40-B8A3-67DBCD9E45C2}" type="datetimeFigureOut">
+            <a:fld id="{47A277B0-1BC8-46D0-96E9-4631C913E98E}" type="datetimeFigureOut">
               <a:rPr lang="en-US" smtClean="0"/>
               <a:t>9/20/2026</a:t>
             </a:fld>
@@ -2677,7 +2677,7 @@
           <p:cNvPr id="6" name="Footer Placeholder 5">
             <a:extLst>
               <a:ext uri="{FF2B5EF4-FFF2-40B4-BE49-F238E27FC236}">
-                <a16:creationId xmlns:a16="http://schemas.microsoft.com/office/drawing/2014/main" id="{D74C4CA4-BDCE-E52B-500B-A6BE0320D44D}"/>
+                <a16:creationId xmlns:a16="http://schemas.microsoft.com/office/drawing/2014/main" id="{9B8312DE-2466-E2DC-CB51-6398C7F62CFA}"/>
               </a:ext>
             </a:extLst>
           </p:cNvPr>
@@ -2702,7 +2702,7 @@
           <p:cNvPr id="7" name="Slide Number Placeholder 6">
             <a:extLst>
               <a:ext uri="{FF2B5EF4-FFF2-40B4-BE49-F238E27FC236}">
-                <a16:creationId xmlns:a16="http://schemas.microsoft.com/office/drawing/2014/main" id="{0CE7CA98-E9CA-95D0-5849-D6D7948A52ED}"/>
+                <a16:creationId xmlns:a16="http://schemas.microsoft.com/office/drawing/2014/main" id="{72524C02-A36D-15AD-B94F-82D3336CDD90}"/>
               </a:ext>
             </a:extLst>
           </p:cNvPr>
@@ -2718,7 +2718,7 @@
           <a:bodyPr/>
           <a:lstStyle/>
           <a:p>
-            <a:fld id="{B7A613CB-FFFC-4DC9-A6CC-F615930E06AC}" type="slidenum">
+            <a:fld id="{50FEEB4A-BAF6-4C97-B33F-AB910F2FB9EF}" type="slidenum">
               <a:rPr lang="en-US" smtClean="0"/>
               <a:t>‹#›</a:t>
             </a:fld>
@@ -2729,7 +2729,7 @@
     </p:spTree>
     <p:extLst>
       <p:ext uri="{BB962C8B-B14F-4D97-AF65-F5344CB8AC3E}">
-        <p14:creationId xmlns:p14="http://schemas.microsoft.com/office/powerpoint/2010/main" val="2289079260"/>
+        <p14:creationId xmlns:p14="http://schemas.microsoft.com/office/powerpoint/2010/main" val="4101634589"/>
       </p:ext>
     </p:extLst>
   </p:cSld>
@@ -2766,7 +2766,7 @@
           <p:cNvPr id="2" name="Title Placeholder 1">
             <a:extLst>
               <a:ext uri="{FF2B5EF4-FFF2-40B4-BE49-F238E27FC236}">
-                <a16:creationId xmlns:a16="http://schemas.microsoft.com/office/drawing/2014/main" id="{750BE623-D211-B3FC-7CD0-839AABC7650E}"/>
+                <a16:creationId xmlns:a16="http://schemas.microsoft.com/office/drawing/2014/main" id="{DF5051FA-D433-D5C6-6DBE-6F1FE71CE95A}"/>
               </a:ext>
             </a:extLst>
           </p:cNvPr>
@@ -2804,7 +2804,7 @@
           <p:cNvPr id="3" name="Text Placeholder 2">
             <a:extLst>
               <a:ext uri="{FF2B5EF4-FFF2-40B4-BE49-F238E27FC236}">
-                <a16:creationId xmlns:a16="http://schemas.microsoft.com/office/drawing/2014/main" id="{8F029AD6-C06F-2CA0-FF29-C530FE1A0590}"/>
+                <a16:creationId xmlns:a16="http://schemas.microsoft.com/office/drawing/2014/main" id="{D6517241-912E-FECF-7617-043176A7C69F}"/>
               </a:ext>
             </a:extLst>
           </p:cNvPr>
@@ -2871,7 +2871,7 @@
           <p:cNvPr id="4" name="Date Placeholder 3">
             <a:extLst>
               <a:ext uri="{FF2B5EF4-FFF2-40B4-BE49-F238E27FC236}">
-                <a16:creationId xmlns:a16="http://schemas.microsoft.com/office/drawing/2014/main" id="{7457A944-9C0D-F18F-F2BE-3C0291CA0327}"/>
+                <a16:creationId xmlns:a16="http://schemas.microsoft.com/office/drawing/2014/main" id="{A8CD0020-964C-EB22-BDA4-DA7D8254A3E6}"/>
               </a:ext>
             </a:extLst>
           </p:cNvPr>
@@ -2905,7 +2905,7 @@
             </a:lvl1pPr>
           </a:lstStyle>
           <a:p>
-            <a:fld id="{CCA853AE-2B35-4E40-B8A3-67DBCD9E45C2}" type="datetimeFigureOut">
+            <a:fld id="{47A277B0-1BC8-46D0-96E9-4631C913E98E}" type="datetimeFigureOut">
               <a:rPr lang="en-US" smtClean="0"/>
               <a:t>9/20/2026</a:t>
             </a:fld>
@@ -2918,7 +2918,7 @@
           <p:cNvPr id="5" name="Footer Placeholder 4">
             <a:extLst>
               <a:ext uri="{FF2B5EF4-FFF2-40B4-BE49-F238E27FC236}">
-                <a16:creationId xmlns:a16="http://schemas.microsoft.com/office/drawing/2014/main" id="{0BBAA115-DB4D-A522-87CC-226B3216813A}"/>
+                <a16:creationId xmlns:a16="http://schemas.microsoft.com/office/drawing/2014/main" id="{EEACF493-55F8-4C78-4345-995F343EF3B8}"/>
               </a:ext>
             </a:extLst>
           </p:cNvPr>
@@ -2961,7 +2961,7 @@
           <p:cNvPr id="6" name="Slide Number Placeholder 5">
             <a:extLst>
               <a:ext uri="{FF2B5EF4-FFF2-40B4-BE49-F238E27FC236}">
-                <a16:creationId xmlns:a16="http://schemas.microsoft.com/office/drawing/2014/main" id="{7E305C29-B6A3-4F33-9686-CA420F1C2EFB}"/>
+                <a16:creationId xmlns:a16="http://schemas.microsoft.com/office/drawing/2014/main" id="{A9C5E859-3BEB-DD1F-F73F-BFDC36263BAE}"/>
               </a:ext>
             </a:extLst>
           </p:cNvPr>
@@ -2995,7 +2995,7 @@
             </a:lvl1pPr>
           </a:lstStyle>
           <a:p>
-            <a:fld id="{B7A613CB-FFFC-4DC9-A6CC-F615930E06AC}" type="slidenum">
+            <a:fld id="{50FEEB4A-BAF6-4C97-B33F-AB910F2FB9EF}" type="slidenum">
               <a:rPr lang="en-US" smtClean="0"/>
               <a:t>‹#›</a:t>
             </a:fld>
@@ -3006,7 +3006,7 @@
     </p:spTree>
     <p:extLst>
       <p:ext uri="{BB962C8B-B14F-4D97-AF65-F5344CB8AC3E}">
-        <p14:creationId xmlns:p14="http://schemas.microsoft.com/office/powerpoint/2010/main" val="2816170949"/>
+        <p14:creationId xmlns:p14="http://schemas.microsoft.com/office/powerpoint/2010/main" val="2556152189"/>
       </p:ext>
     </p:extLst>
   </p:cSld>
@@ -3329,7 +3329,7 @@
           <p:cNvPr id="2" name="Rectangle 1">
             <a:extLst>
               <a:ext uri="{FF2B5EF4-FFF2-40B4-BE49-F238E27FC236}">
-                <a16:creationId xmlns:a16="http://schemas.microsoft.com/office/drawing/2014/main" id="{63CA4D8F-9828-644B-D4B0-8047E5C7B663}"/>
+                <a16:creationId xmlns:a16="http://schemas.microsoft.com/office/drawing/2014/main" id="{BB9964E5-453C-2B7E-8AD0-498D70E3B7A2}"/>
               </a:ext>
             </a:extLst>
           </p:cNvPr>
@@ -3397,7 +3397,7 @@
           <p:cNvPr id="3" name="Rectangle 2">
             <a:extLst>
               <a:ext uri="{FF2B5EF4-FFF2-40B4-BE49-F238E27FC236}">
-                <a16:creationId xmlns:a16="http://schemas.microsoft.com/office/drawing/2014/main" id="{BC02FAFA-B5FE-95C5-E15F-D8F837CB231F}"/>
+                <a16:creationId xmlns:a16="http://schemas.microsoft.com/office/drawing/2014/main" id="{B177AB9C-1333-1D54-866E-013CEB68DBB3}"/>
               </a:ext>
             </a:extLst>
           </p:cNvPr>
@@ -3465,7 +3465,7 @@
           <p:cNvPr id="4" name="TextBox 3">
             <a:extLst>
               <a:ext uri="{FF2B5EF4-FFF2-40B4-BE49-F238E27FC236}">
-                <a16:creationId xmlns:a16="http://schemas.microsoft.com/office/drawing/2014/main" id="{DE71A7C5-DB7E-38AA-4938-D8B0AE0BD8FE}"/>
+                <a16:creationId xmlns:a16="http://schemas.microsoft.com/office/drawing/2014/main" id="{83F5A016-7C8A-E876-B2F9-E8858F4886B3}"/>
               </a:ext>
             </a:extLst>
           </p:cNvPr>
@@ -3505,7 +3505,7 @@
           <p:cNvPr id="5" name="TextBox 4">
             <a:extLst>
               <a:ext uri="{FF2B5EF4-FFF2-40B4-BE49-F238E27FC236}">
-                <a16:creationId xmlns:a16="http://schemas.microsoft.com/office/drawing/2014/main" id="{DC4E5585-5798-80CB-3533-ACA50AF8933E}"/>
+                <a16:creationId xmlns:a16="http://schemas.microsoft.com/office/drawing/2014/main" id="{B735C7FE-82A2-7EE8-CE37-68984EBDE804}"/>
               </a:ext>
             </a:extLst>
           </p:cNvPr>
@@ -3546,7 +3546,7 @@
           <p:cNvPr id="6" name="TextBox 5">
             <a:extLst>
               <a:ext uri="{FF2B5EF4-FFF2-40B4-BE49-F238E27FC236}">
-                <a16:creationId xmlns:a16="http://schemas.microsoft.com/office/drawing/2014/main" id="{52C9C138-9B08-C162-58A9-36D19CC0E8D0}"/>
+                <a16:creationId xmlns:a16="http://schemas.microsoft.com/office/drawing/2014/main" id="{8D78DE3D-F78D-D572-4CEA-5D87E42ECFB9}"/>
               </a:ext>
             </a:extLst>
           </p:cNvPr>
@@ -3586,7 +3586,7 @@
           <p:cNvPr id="7" name="Rectangle: Rounded Corners 6">
             <a:extLst>
               <a:ext uri="{FF2B5EF4-FFF2-40B4-BE49-F238E27FC236}">
-                <a16:creationId xmlns:a16="http://schemas.microsoft.com/office/drawing/2014/main" id="{C7DCBDFF-C929-E1D9-7B8A-40956AEDD961}"/>
+                <a16:creationId xmlns:a16="http://schemas.microsoft.com/office/drawing/2014/main" id="{113A221E-69F9-2F1D-0AD4-4CC391C0EA18}"/>
               </a:ext>
             </a:extLst>
           </p:cNvPr>
@@ -3654,7 +3654,7 @@
           <p:cNvPr id="8" name="TextBox 7">
             <a:extLst>
               <a:ext uri="{FF2B5EF4-FFF2-40B4-BE49-F238E27FC236}">
-                <a16:creationId xmlns:a16="http://schemas.microsoft.com/office/drawing/2014/main" id="{0CB0045E-8A0A-C906-C5A1-5538DE4C9910}"/>
+                <a16:creationId xmlns:a16="http://schemas.microsoft.com/office/drawing/2014/main" id="{DDD3E075-0F3D-6CE2-65FB-0186EFAB32DD}"/>
               </a:ext>
             </a:extLst>
           </p:cNvPr>
@@ -3694,7 +3694,7 @@
           <p:cNvPr id="9" name="TextBox 8">
             <a:extLst>
               <a:ext uri="{FF2B5EF4-FFF2-40B4-BE49-F238E27FC236}">
-                <a16:creationId xmlns:a16="http://schemas.microsoft.com/office/drawing/2014/main" id="{E580C2BF-3711-314B-064B-D63C623CF8B2}"/>
+                <a16:creationId xmlns:a16="http://schemas.microsoft.com/office/drawing/2014/main" id="{FE3C9ED7-FBAC-A7AB-DEA3-928386D71D3A}"/>
               </a:ext>
             </a:extLst>
           </p:cNvPr>
@@ -3734,7 +3734,7 @@
           <p:cNvPr id="10" name="Rectangle: Rounded Corners 9">
             <a:extLst>
               <a:ext uri="{FF2B5EF4-FFF2-40B4-BE49-F238E27FC236}">
-                <a16:creationId xmlns:a16="http://schemas.microsoft.com/office/drawing/2014/main" id="{CE8B1A37-214C-8DC0-E3FA-672125A82256}"/>
+                <a16:creationId xmlns:a16="http://schemas.microsoft.com/office/drawing/2014/main" id="{1CE41354-AE33-DA76-3716-0AD957BDD75A}"/>
               </a:ext>
             </a:extLst>
           </p:cNvPr>
@@ -3804,7 +3804,7 @@
           <p:cNvPr id="12" name="Picture 11">
             <a:extLst>
               <a:ext uri="{FF2B5EF4-FFF2-40B4-BE49-F238E27FC236}">
-                <a16:creationId xmlns:a16="http://schemas.microsoft.com/office/drawing/2014/main" id="{4811790A-DE01-1B2A-CE61-CB02FDE6E223}"/>
+                <a16:creationId xmlns:a16="http://schemas.microsoft.com/office/drawing/2014/main" id="{5D40B604-5563-0873-69D8-20A5C270E982}"/>
               </a:ext>
             </a:extLst>
           </p:cNvPr>
@@ -3827,8 +3827,8 @@
         </p:blipFill>
         <p:spPr>
           <a:xfrm>
-            <a:off x="5918200" y="1147943"/>
-            <a:ext cx="5410200" cy="4562115"/>
+            <a:off x="6817757" y="889000"/>
+            <a:ext cx="3611084" cy="5080000"/>
           </a:xfrm>
           <a:prstGeom prst="rect">
             <a:avLst/>
@@ -3838,7 +3838,7 @@
     </p:spTree>
     <p:extLst>
       <p:ext uri="{BB962C8B-B14F-4D97-AF65-F5344CB8AC3E}">
-        <p14:creationId xmlns:p14="http://schemas.microsoft.com/office/powerpoint/2010/main" val="1433513114"/>
+        <p14:creationId xmlns:p14="http://schemas.microsoft.com/office/powerpoint/2010/main" val="1025460918"/>
       </p:ext>
     </p:extLst>
   </p:cSld>
@@ -3878,7 +3878,7 @@
           <p:cNvPr id="2" name="TextBox 1">
             <a:extLst>
               <a:ext uri="{FF2B5EF4-FFF2-40B4-BE49-F238E27FC236}">
-                <a16:creationId xmlns:a16="http://schemas.microsoft.com/office/drawing/2014/main" id="{73499B08-D036-AE1B-CBB1-D162A26B029A}"/>
+                <a16:creationId xmlns:a16="http://schemas.microsoft.com/office/drawing/2014/main" id="{C5B297D3-E099-36D2-667D-47396CE56A72}"/>
               </a:ext>
             </a:extLst>
           </p:cNvPr>
@@ -3918,7 +3918,7 @@
           <p:cNvPr id="3" name="TextBox 2">
             <a:extLst>
               <a:ext uri="{FF2B5EF4-FFF2-40B4-BE49-F238E27FC236}">
-                <a16:creationId xmlns:a16="http://schemas.microsoft.com/office/drawing/2014/main" id="{692670A8-C260-A8F4-B800-4D060C6CD518}"/>
+                <a16:creationId xmlns:a16="http://schemas.microsoft.com/office/drawing/2014/main" id="{CD8204AB-12A7-8215-EC79-8E1905F88B7B}"/>
               </a:ext>
             </a:extLst>
           </p:cNvPr>
@@ -3958,7 +3958,7 @@
           <p:cNvPr id="4" name="TextBox 3">
             <a:extLst>
               <a:ext uri="{FF2B5EF4-FFF2-40B4-BE49-F238E27FC236}">
-                <a16:creationId xmlns:a16="http://schemas.microsoft.com/office/drawing/2014/main" id="{C48CFC69-71C8-7AF9-4DCD-593716C100CA}"/>
+                <a16:creationId xmlns:a16="http://schemas.microsoft.com/office/drawing/2014/main" id="{2B9821ED-5705-0A39-4A9D-B4DFAEB250BD}"/>
               </a:ext>
             </a:extLst>
           </p:cNvPr>
@@ -3998,7 +3998,7 @@
           <p:cNvPr id="5" name="Rectangle 4">
             <a:extLst>
               <a:ext uri="{FF2B5EF4-FFF2-40B4-BE49-F238E27FC236}">
-                <a16:creationId xmlns:a16="http://schemas.microsoft.com/office/drawing/2014/main" id="{547C3027-C6E4-7AAC-AB7D-609F21BEBB8E}"/>
+                <a16:creationId xmlns:a16="http://schemas.microsoft.com/office/drawing/2014/main" id="{D560FD55-EBD8-27E6-50E8-61B32D2E004A}"/>
               </a:ext>
             </a:extLst>
           </p:cNvPr>
@@ -4066,7 +4066,7 @@
           <p:cNvPr id="6" name="Rectangle: Rounded Corners 5">
             <a:extLst>
               <a:ext uri="{FF2B5EF4-FFF2-40B4-BE49-F238E27FC236}">
-                <a16:creationId xmlns:a16="http://schemas.microsoft.com/office/drawing/2014/main" id="{C8F8B582-68E0-1E4E-F797-AC34C7D0B809}"/>
+                <a16:creationId xmlns:a16="http://schemas.microsoft.com/office/drawing/2014/main" id="{B624B693-E261-83CC-5EEC-F85443102F08}"/>
               </a:ext>
             </a:extLst>
           </p:cNvPr>
@@ -4120,7 +4120,7 @@
           <p:cNvPr id="8" name="Picture 7">
             <a:extLst>
               <a:ext uri="{FF2B5EF4-FFF2-40B4-BE49-F238E27FC236}">
-                <a16:creationId xmlns:a16="http://schemas.microsoft.com/office/drawing/2014/main" id="{ABD5234A-9F40-AB2A-BA4C-02EFB1903F56}"/>
+                <a16:creationId xmlns:a16="http://schemas.microsoft.com/office/drawing/2014/main" id="{91FAB889-6C0C-3326-4453-65A35F61045D}"/>
               </a:ext>
             </a:extLst>
           </p:cNvPr>
@@ -4143,8 +4143,8 @@
         </p:blipFill>
         <p:spPr>
           <a:xfrm>
-            <a:off x="3641074" y="2006600"/>
-            <a:ext cx="4909853" cy="4140200"/>
+            <a:off x="4624483" y="2006600"/>
+            <a:ext cx="2943034" cy="4140200"/>
           </a:xfrm>
           <a:prstGeom prst="rect">
             <a:avLst/>
@@ -4156,7 +4156,7 @@
           <p:cNvPr id="9" name="TextBox 8">
             <a:extLst>
               <a:ext uri="{FF2B5EF4-FFF2-40B4-BE49-F238E27FC236}">
-                <a16:creationId xmlns:a16="http://schemas.microsoft.com/office/drawing/2014/main" id="{4115C75A-28E0-8453-34F7-D439C60F85CD}"/>
+                <a16:creationId xmlns:a16="http://schemas.microsoft.com/office/drawing/2014/main" id="{517B1072-E173-B9CE-BAC4-112AC64BD427}"/>
               </a:ext>
             </a:extLst>
           </p:cNvPr>
@@ -4196,7 +4196,7 @@
           <p:cNvPr id="10" name="TextBox 9">
             <a:extLst>
               <a:ext uri="{FF2B5EF4-FFF2-40B4-BE49-F238E27FC236}">
-                <a16:creationId xmlns:a16="http://schemas.microsoft.com/office/drawing/2014/main" id="{B838AC46-01DF-6510-C513-81F25959BDE6}"/>
+                <a16:creationId xmlns:a16="http://schemas.microsoft.com/office/drawing/2014/main" id="{C0379359-F237-CAFD-5949-271E101A9F3A}"/>
               </a:ext>
             </a:extLst>
           </p:cNvPr>
@@ -4235,7 +4235,7 @@
     </p:spTree>
     <p:extLst>
       <p:ext uri="{BB962C8B-B14F-4D97-AF65-F5344CB8AC3E}">
-        <p14:creationId xmlns:p14="http://schemas.microsoft.com/office/powerpoint/2010/main" val="3169465346"/>
+        <p14:creationId xmlns:p14="http://schemas.microsoft.com/office/powerpoint/2010/main" val="3685596552"/>
       </p:ext>
     </p:extLst>
   </p:cSld>
@@ -4275,7 +4275,7 @@
           <p:cNvPr id="2" name="TextBox 1">
             <a:extLst>
               <a:ext uri="{FF2B5EF4-FFF2-40B4-BE49-F238E27FC236}">
-                <a16:creationId xmlns:a16="http://schemas.microsoft.com/office/drawing/2014/main" id="{3083C2B6-5D9E-7FE2-923F-94CE84CC99A9}"/>
+                <a16:creationId xmlns:a16="http://schemas.microsoft.com/office/drawing/2014/main" id="{79E443E7-13E2-15AE-B256-69B2B3A58ADC}"/>
               </a:ext>
             </a:extLst>
           </p:cNvPr>
@@ -4315,7 +4315,7 @@
           <p:cNvPr id="3" name="TextBox 2">
             <a:extLst>
               <a:ext uri="{FF2B5EF4-FFF2-40B4-BE49-F238E27FC236}">
-                <a16:creationId xmlns:a16="http://schemas.microsoft.com/office/drawing/2014/main" id="{53664286-EA52-28EE-7C8F-992D7E077886}"/>
+                <a16:creationId xmlns:a16="http://schemas.microsoft.com/office/drawing/2014/main" id="{AC0B4C2D-FFAB-D447-FDCC-6A557273490A}"/>
               </a:ext>
             </a:extLst>
           </p:cNvPr>
@@ -4355,7 +4355,7 @@
           <p:cNvPr id="4" name="TextBox 3">
             <a:extLst>
               <a:ext uri="{FF2B5EF4-FFF2-40B4-BE49-F238E27FC236}">
-                <a16:creationId xmlns:a16="http://schemas.microsoft.com/office/drawing/2014/main" id="{ECA7763A-F0FE-A394-667F-23E01531F4FA}"/>
+                <a16:creationId xmlns:a16="http://schemas.microsoft.com/office/drawing/2014/main" id="{BFCFC6F9-3E21-3E2E-0C49-8A5F0C1DD323}"/>
               </a:ext>
             </a:extLst>
           </p:cNvPr>
@@ -4395,7 +4395,7 @@
           <p:cNvPr id="5" name="Rectangle 4">
             <a:extLst>
               <a:ext uri="{FF2B5EF4-FFF2-40B4-BE49-F238E27FC236}">
-                <a16:creationId xmlns:a16="http://schemas.microsoft.com/office/drawing/2014/main" id="{EBCE71E0-EF38-C0CD-6610-7D2E0F708DBC}"/>
+                <a16:creationId xmlns:a16="http://schemas.microsoft.com/office/drawing/2014/main" id="{24858D93-C285-2F5A-E1FF-035BC2FDECF1}"/>
               </a:ext>
             </a:extLst>
           </p:cNvPr>
@@ -4463,7 +4463,7 @@
           <p:cNvPr id="6" name="Rectangle: Rounded Corners 5">
             <a:extLst>
               <a:ext uri="{FF2B5EF4-FFF2-40B4-BE49-F238E27FC236}">
-                <a16:creationId xmlns:a16="http://schemas.microsoft.com/office/drawing/2014/main" id="{BC376F2A-C382-7BA5-C194-F3A6B8BDEAA7}"/>
+                <a16:creationId xmlns:a16="http://schemas.microsoft.com/office/drawing/2014/main" id="{61CA5186-4CE5-0FCA-68CC-2CC930A5464F}"/>
               </a:ext>
             </a:extLst>
           </p:cNvPr>
@@ -4517,7 +4517,7 @@
           <p:cNvPr id="8" name="Picture 7">
             <a:extLst>
               <a:ext uri="{FF2B5EF4-FFF2-40B4-BE49-F238E27FC236}">
-                <a16:creationId xmlns:a16="http://schemas.microsoft.com/office/drawing/2014/main" id="{A353B408-847D-832B-65B7-E15B2F52FC58}"/>
+                <a16:creationId xmlns:a16="http://schemas.microsoft.com/office/drawing/2014/main" id="{57CE9E9A-F982-8825-7F81-CACBDCAD2D0B}"/>
               </a:ext>
             </a:extLst>
           </p:cNvPr>
@@ -4540,8 +4540,8 @@
         </p:blipFill>
         <p:spPr>
           <a:xfrm>
-            <a:off x="3641074" y="2006600"/>
-            <a:ext cx="4909853" cy="4140200"/>
+            <a:off x="3644566" y="2006600"/>
+            <a:ext cx="4902869" cy="4140200"/>
           </a:xfrm>
           <a:prstGeom prst="rect">
             <a:avLst/>
@@ -4553,7 +4553,7 @@
           <p:cNvPr id="9" name="TextBox 8">
             <a:extLst>
               <a:ext uri="{FF2B5EF4-FFF2-40B4-BE49-F238E27FC236}">
-                <a16:creationId xmlns:a16="http://schemas.microsoft.com/office/drawing/2014/main" id="{D87BF2BD-6D31-B752-D732-887D516FAB29}"/>
+                <a16:creationId xmlns:a16="http://schemas.microsoft.com/office/drawing/2014/main" id="{0132F9CA-DFCC-B143-99C1-062C0656C174}"/>
               </a:ext>
             </a:extLst>
           </p:cNvPr>
@@ -4593,7 +4593,7 @@
           <p:cNvPr id="10" name="TextBox 9">
             <a:extLst>
               <a:ext uri="{FF2B5EF4-FFF2-40B4-BE49-F238E27FC236}">
-                <a16:creationId xmlns:a16="http://schemas.microsoft.com/office/drawing/2014/main" id="{91018F33-6E0A-CB8D-391B-9695B54A3C86}"/>
+                <a16:creationId xmlns:a16="http://schemas.microsoft.com/office/drawing/2014/main" id="{3B7BEF95-59E5-1FD5-C7BA-6AC8AF417C54}"/>
               </a:ext>
             </a:extLst>
           </p:cNvPr>
@@ -4632,7 +4632,7 @@
     </p:spTree>
     <p:extLst>
       <p:ext uri="{BB962C8B-B14F-4D97-AF65-F5344CB8AC3E}">
-        <p14:creationId xmlns:p14="http://schemas.microsoft.com/office/powerpoint/2010/main" val="2690117911"/>
+        <p14:creationId xmlns:p14="http://schemas.microsoft.com/office/powerpoint/2010/main" val="3303974672"/>
       </p:ext>
     </p:extLst>
   </p:cSld>
@@ -4672,7 +4672,7 @@
           <p:cNvPr id="2" name="TextBox 1">
             <a:extLst>
               <a:ext uri="{FF2B5EF4-FFF2-40B4-BE49-F238E27FC236}">
-                <a16:creationId xmlns:a16="http://schemas.microsoft.com/office/drawing/2014/main" id="{D5D075C5-F5D8-EEF7-756A-784E091FB974}"/>
+                <a16:creationId xmlns:a16="http://schemas.microsoft.com/office/drawing/2014/main" id="{CD8A2C0D-409F-3A64-B8CC-496932CDBBFB}"/>
               </a:ext>
             </a:extLst>
           </p:cNvPr>
@@ -4712,7 +4712,7 @@
           <p:cNvPr id="3" name="TextBox 2">
             <a:extLst>
               <a:ext uri="{FF2B5EF4-FFF2-40B4-BE49-F238E27FC236}">
-                <a16:creationId xmlns:a16="http://schemas.microsoft.com/office/drawing/2014/main" id="{A144BEB8-8CC6-0A96-7D02-7BC272C6EA23}"/>
+                <a16:creationId xmlns:a16="http://schemas.microsoft.com/office/drawing/2014/main" id="{5539E034-BDEB-0310-C9A0-6F801A31ACF9}"/>
               </a:ext>
             </a:extLst>
           </p:cNvPr>
@@ -4752,7 +4752,7 @@
           <p:cNvPr id="4" name="TextBox 3">
             <a:extLst>
               <a:ext uri="{FF2B5EF4-FFF2-40B4-BE49-F238E27FC236}">
-                <a16:creationId xmlns:a16="http://schemas.microsoft.com/office/drawing/2014/main" id="{896915E1-5CC3-8257-F844-B0819EDB8216}"/>
+                <a16:creationId xmlns:a16="http://schemas.microsoft.com/office/drawing/2014/main" id="{FF4D89DF-FF46-9A26-7582-FB1BE453208D}"/>
               </a:ext>
             </a:extLst>
           </p:cNvPr>
@@ -4792,7 +4792,7 @@
           <p:cNvPr id="5" name="Rectangle 4">
             <a:extLst>
               <a:ext uri="{FF2B5EF4-FFF2-40B4-BE49-F238E27FC236}">
-                <a16:creationId xmlns:a16="http://schemas.microsoft.com/office/drawing/2014/main" id="{30189BED-EFC0-C22E-6982-71C3E142460C}"/>
+                <a16:creationId xmlns:a16="http://schemas.microsoft.com/office/drawing/2014/main" id="{82FECBF1-0974-37BC-FEAE-95543F3775C2}"/>
               </a:ext>
             </a:extLst>
           </p:cNvPr>
@@ -4860,7 +4860,7 @@
           <p:cNvPr id="6" name="Rectangle: Rounded Corners 5">
             <a:extLst>
               <a:ext uri="{FF2B5EF4-FFF2-40B4-BE49-F238E27FC236}">
-                <a16:creationId xmlns:a16="http://schemas.microsoft.com/office/drawing/2014/main" id="{FB851444-483E-FA89-C6C3-83F2941C120F}"/>
+                <a16:creationId xmlns:a16="http://schemas.microsoft.com/office/drawing/2014/main" id="{D8F89C63-C428-2440-E333-C38FFCF7EEC0}"/>
               </a:ext>
             </a:extLst>
           </p:cNvPr>
@@ -4914,7 +4914,7 @@
           <p:cNvPr id="8" name="Picture 7">
             <a:extLst>
               <a:ext uri="{FF2B5EF4-FFF2-40B4-BE49-F238E27FC236}">
-                <a16:creationId xmlns:a16="http://schemas.microsoft.com/office/drawing/2014/main" id="{A468FC9F-DAE2-91A4-E2E3-EF4E6DB03938}"/>
+                <a16:creationId xmlns:a16="http://schemas.microsoft.com/office/drawing/2014/main" id="{65E803FC-745A-454B-3CBD-0454F47E116B}"/>
               </a:ext>
             </a:extLst>
           </p:cNvPr>
@@ -4937,8 +4937,8 @@
         </p:blipFill>
         <p:spPr>
           <a:xfrm>
-            <a:off x="3641074" y="2006600"/>
-            <a:ext cx="4909853" cy="4140200"/>
+            <a:off x="3644566" y="2006600"/>
+            <a:ext cx="4902869" cy="4140200"/>
           </a:xfrm>
           <a:prstGeom prst="rect">
             <a:avLst/>
@@ -4950,7 +4950,7 @@
           <p:cNvPr id="9" name="TextBox 8">
             <a:extLst>
               <a:ext uri="{FF2B5EF4-FFF2-40B4-BE49-F238E27FC236}">
-                <a16:creationId xmlns:a16="http://schemas.microsoft.com/office/drawing/2014/main" id="{AD2B2190-8AB0-7351-CF81-4849321EB483}"/>
+                <a16:creationId xmlns:a16="http://schemas.microsoft.com/office/drawing/2014/main" id="{06C4AB91-6982-EC7B-14C5-6155D343D399}"/>
               </a:ext>
             </a:extLst>
           </p:cNvPr>
@@ -4990,7 +4990,7 @@
           <p:cNvPr id="10" name="TextBox 9">
             <a:extLst>
               <a:ext uri="{FF2B5EF4-FFF2-40B4-BE49-F238E27FC236}">
-                <a16:creationId xmlns:a16="http://schemas.microsoft.com/office/drawing/2014/main" id="{7D79E02B-754A-2348-9DD4-50018832B3AE}"/>
+                <a16:creationId xmlns:a16="http://schemas.microsoft.com/office/drawing/2014/main" id="{DDC8A1FE-1CDB-1153-B1F6-936E76C2E588}"/>
               </a:ext>
             </a:extLst>
           </p:cNvPr>
@@ -5029,7 +5029,7 @@
     </p:spTree>
     <p:extLst>
       <p:ext uri="{BB962C8B-B14F-4D97-AF65-F5344CB8AC3E}">
-        <p14:creationId xmlns:p14="http://schemas.microsoft.com/office/powerpoint/2010/main" val="2775520144"/>
+        <p14:creationId xmlns:p14="http://schemas.microsoft.com/office/powerpoint/2010/main" val="863903266"/>
       </p:ext>
     </p:extLst>
   </p:cSld>

</xml_diff>